<commit_message>
Add proposal figures and slides for scheduling algorithms
- Created package.json for project dependencies including Playwright, pptxgenjs, and sharp.
- Added PowerPoint presentation (proposal-figures.pptx) for visual representation of proposal.
- Introduced HTML slides detailing algorithm comparisons, concept mapping, architecture, and performance metrics.
- Included a backup of the original concept mapping slide before replacement.
- Added a final proposal document (proposal.docx) and a snapshot info file documenting the snapshot creation details.
</commit_message>
<xml_diff>
--- a/04-proposal/figures/proposal-figures.pptx
+++ b/04-proposal/figures/proposal-figures.pptx
@@ -4129,7 +4129,7 @@
         <p:spPr>
           <a:xfrm>
             <a:off x="381000" y="2945904"/>
-            <a:ext cx="8382000" cy="453926"/>
+            <a:ext cx="5857429" cy="577751"/>
           </a:xfrm>
           <a:prstGeom prst="rect">
             <a:avLst/>
@@ -4160,7 +4160,7 @@
         </p:nvSpPr>
         <p:spPr>
           <a:xfrm>
-            <a:off x="400050" y="2964954"/>
+            <a:off x="400050" y="3026866"/>
             <a:ext cx="2590800" cy="415826"/>
           </a:xfrm>
           <a:prstGeom prst="rect">
@@ -4190,7 +4190,7 @@
         </p:nvSpPr>
         <p:spPr>
           <a:xfrm>
-            <a:off x="552450" y="3091904"/>
+            <a:off x="552450" y="3153817"/>
             <a:ext cx="2331720" cy="161925"/>
           </a:xfrm>
           <a:prstGeom prst="rect">
@@ -4229,8 +4229,8 @@
         </p:nvSpPr>
         <p:spPr>
           <a:xfrm>
-            <a:off x="3194000" y="3096667"/>
-            <a:ext cx="3154501" cy="152400"/>
+            <a:off x="3194000" y="3158579"/>
+            <a:ext cx="1890120" cy="152400"/>
           </a:xfrm>
           <a:prstGeom prst="rect">
             <a:avLst/>
@@ -4254,7 +4254,7 @@
                 <a:ea typeface="Malgun Gothic" pitchFamily="34" charset="-122"/>
                 <a:cs typeface="Malgun Gothic" pitchFamily="34" charset="-120"/>
               </a:rPr>
-              <a:t>메모리 배열 (큐) · JSON 파일 (로그) · Ollama (LLM 백엔드)</a:t>
+              <a:t>메모리 배열 (큐) · JSON 파일 (로그)</a:t>
             </a:r>
             <a:endParaRPr lang="en-US" sz="1000" dirty="0"/>
           </a:p>
@@ -4262,7 +4262,225 @@
       </p:sp>
       <p:sp>
         <p:nvSpPr>
-          <p:cNvPr id="33" name="Shape 31"/>
+          <p:cNvPr id="33" name="Text 31"/>
+          <p:cNvSpPr/>
+          <p:nvPr/>
+        </p:nvSpPr>
+        <p:spPr>
+          <a:xfrm>
+            <a:off x="6339929" y="2945904"/>
+            <a:ext cx="2423071" cy="577751"/>
+          </a:xfrm>
+          <a:prstGeom prst="rect">
+            <a:avLst/>
+          </a:prstGeom>
+          <a:noFill/>
+          <a:ln w="19050">
+            <a:solidFill>
+              <a:srgbClr val="333333"/>
+            </a:solidFill>
+          </a:ln>
+        </p:spPr>
+        <p:txBody>
+          <a:bodyPr wrap="square" rtlCol="0" anchor="ctr"/>
+          <a:lstStyle/>
+          <a:p>
+            <a:pPr indent="0" marL="0">
+              <a:buNone/>
+            </a:pPr>
+            <a:endParaRPr lang="en-US" dirty="0"/>
+          </a:p>
+        </p:txBody>
+      </p:sp>
+      <p:sp>
+        <p:nvSpPr>
+          <p:cNvPr id="34" name="Text 32"/>
+          <p:cNvSpPr/>
+          <p:nvPr/>
+        </p:nvSpPr>
+        <p:spPr>
+          <a:xfrm>
+            <a:off x="6358979" y="2964954"/>
+            <a:ext cx="992981" cy="539651"/>
+          </a:xfrm>
+          <a:prstGeom prst="rect">
+            <a:avLst/>
+          </a:prstGeom>
+          <a:solidFill>
+            <a:srgbClr val="333333"/>
+          </a:solidFill>
+          <a:ln/>
+        </p:spPr>
+        <p:txBody>
+          <a:bodyPr wrap="square" rtlCol="0" anchor="ctr"/>
+          <a:lstStyle/>
+          <a:p>
+            <a:pPr indent="0" marL="0">
+              <a:buNone/>
+            </a:pPr>
+            <a:endParaRPr lang="en-US" dirty="0"/>
+          </a:p>
+        </p:txBody>
+      </p:sp>
+      <p:sp>
+        <p:nvSpPr>
+          <p:cNvPr id="35" name="Text 33"/>
+          <p:cNvSpPr/>
+          <p:nvPr/>
+        </p:nvSpPr>
+        <p:spPr>
+          <a:xfrm>
+            <a:off x="6511379" y="3091904"/>
+            <a:ext cx="701945" cy="161925"/>
+          </a:xfrm>
+          <a:prstGeom prst="rect">
+            <a:avLst/>
+          </a:prstGeom>
+          <a:noFill/>
+          <a:ln/>
+        </p:spPr>
+        <p:txBody>
+          <a:bodyPr wrap="square" lIns="0" tIns="0" rIns="0" bIns="0" rtlCol="0" anchor="t"/>
+          <a:lstStyle/>
+          <a:p>
+            <a:pPr algn="l" indent="0" marL="0">
+              <a:buNone/>
+            </a:pPr>
+            <a:r>
+              <a:rPr lang="en-US" sz="1100" b="1" dirty="0">
+                <a:solidFill>
+                  <a:srgbClr val="FFFFFF"/>
+                </a:solidFill>
+                <a:latin typeface="Malgun Gothic" pitchFamily="34" charset="0"/>
+                <a:ea typeface="Malgun Gothic" pitchFamily="34" charset="-122"/>
+                <a:cs typeface="Malgun Gothic" pitchFamily="34" charset="-120"/>
+              </a:rPr>
+              <a:t>LLM 백엔드</a:t>
+            </a:r>
+            <a:endParaRPr lang="en-US" sz="1100" dirty="0"/>
+          </a:p>
+        </p:txBody>
+      </p:sp>
+      <p:sp>
+        <p:nvSpPr>
+          <p:cNvPr id="36" name="Text 34"/>
+          <p:cNvSpPr/>
+          <p:nvPr/>
+        </p:nvSpPr>
+        <p:spPr>
+          <a:xfrm>
+            <a:off x="6511379" y="3253829"/>
+            <a:ext cx="701945" cy="123825"/>
+          </a:xfrm>
+          <a:prstGeom prst="rect">
+            <a:avLst/>
+          </a:prstGeom>
+          <a:noFill/>
+          <a:ln/>
+        </p:spPr>
+        <p:txBody>
+          <a:bodyPr wrap="square" lIns="0" tIns="0" rIns="0" bIns="0" rtlCol="0" anchor="t"/>
+          <a:lstStyle/>
+          <a:p>
+            <a:pPr algn="l" indent="0" marL="0">
+              <a:buNone/>
+            </a:pPr>
+            <a:r>
+              <a:rPr lang="en-US" sz="800" dirty="0">
+                <a:solidFill>
+                  <a:srgbClr val="CCCCCC"/>
+                </a:solidFill>
+                <a:latin typeface="Malgun Gothic" pitchFamily="34" charset="0"/>
+                <a:ea typeface="Malgun Gothic" pitchFamily="34" charset="-122"/>
+                <a:cs typeface="Malgun Gothic" pitchFamily="34" charset="-120"/>
+              </a:rPr>
+              <a:t>(외부 서비스)</a:t>
+            </a:r>
+            <a:endParaRPr lang="en-US" sz="800" dirty="0"/>
+          </a:p>
+        </p:txBody>
+      </p:sp>
+      <p:sp>
+        <p:nvSpPr>
+          <p:cNvPr id="37" name="Text 35"/>
+          <p:cNvSpPr/>
+          <p:nvPr/>
+        </p:nvSpPr>
+        <p:spPr>
+          <a:xfrm>
+            <a:off x="7555111" y="3163342"/>
+            <a:ext cx="410328" cy="142875"/>
+          </a:xfrm>
+          <a:prstGeom prst="rect">
+            <a:avLst/>
+          </a:prstGeom>
+          <a:noFill/>
+          <a:ln/>
+        </p:spPr>
+        <p:txBody>
+          <a:bodyPr wrap="square" lIns="0" tIns="0" rIns="0" bIns="0" rtlCol="0" anchor="t"/>
+          <a:lstStyle/>
+          <a:p>
+            <a:pPr algn="l" indent="0" marL="0">
+              <a:buNone/>
+            </a:pPr>
+            <a:r>
+              <a:rPr lang="en-US" sz="1000" dirty="0">
+                <a:solidFill>
+                  <a:srgbClr val="333333"/>
+                </a:solidFill>
+                <a:latin typeface="Malgun Gothic" pitchFamily="34" charset="0"/>
+                <a:ea typeface="Malgun Gothic" pitchFamily="34" charset="-122"/>
+                <a:cs typeface="Malgun Gothic" pitchFamily="34" charset="-120"/>
+              </a:rPr>
+              <a:t>Ollama</a:t>
+            </a:r>
+            <a:endParaRPr lang="en-US" sz="1000" dirty="0"/>
+          </a:p>
+        </p:txBody>
+      </p:sp>
+      <p:sp>
+        <p:nvSpPr>
+          <p:cNvPr id="38" name="Text 36"/>
+          <p:cNvSpPr/>
+          <p:nvPr/>
+        </p:nvSpPr>
+        <p:spPr>
+          <a:xfrm>
+            <a:off x="7957393" y="3172867"/>
+            <a:ext cx="595074" cy="123825"/>
+          </a:xfrm>
+          <a:prstGeom prst="rect">
+            <a:avLst/>
+          </a:prstGeom>
+          <a:noFill/>
+          <a:ln/>
+        </p:spPr>
+        <p:txBody>
+          <a:bodyPr wrap="square" lIns="0" tIns="0" rIns="0" bIns="0" rtlCol="0" anchor="t"/>
+          <a:lstStyle/>
+          <a:p>
+            <a:pPr algn="l" indent="0" marL="0">
+              <a:buNone/>
+            </a:pPr>
+            <a:r>
+              <a:rPr lang="en-US" sz="800" dirty="0">
+                <a:solidFill>
+                  <a:srgbClr val="666666"/>
+                </a:solidFill>
+                <a:latin typeface="Malgun Gothic" pitchFamily="34" charset="0"/>
+                <a:ea typeface="Malgun Gothic" pitchFamily="34" charset="-122"/>
+                <a:cs typeface="Malgun Gothic" pitchFamily="34" charset="-120"/>
+              </a:rPr>
+              <a:t>로컬 추론 엔진</a:t>
+            </a:r>
+            <a:endParaRPr lang="en-US" sz="800" dirty="0"/>
+          </a:p>
+        </p:txBody>
+      </p:sp>
+      <p:sp>
+        <p:nvSpPr>
+          <p:cNvPr id="39" name="Shape 37"/>
           <p:cNvSpPr/>
           <p:nvPr/>
         </p:nvSpPr>
@@ -4285,7 +4503,7 @@
       </p:sp>
       <p:sp>
         <p:nvSpPr>
-          <p:cNvPr id="34" name="Text 32"/>
+          <p:cNvPr id="40" name="Text 38"/>
           <p:cNvSpPr/>
           <p:nvPr/>
         </p:nvSpPr>

</xml_diff>

<commit_message>
Add initial proposal files and figures for snapshot 20260308
- Created package.json for figures with dependencies: playwright, pptxgenjs, sharp.
- Added proposal-figures.pptx for visual representation of the proposal.
- Introduced HTML slides for algorithm comparison, architecture, and request flow.
- Included a .gitkeep file in the final directory to maintain structure.
- Added proposal.docx as the main document for the proposal.
- Created snapshot-info.md to document the snapshot creation details and status.
</commit_message>
<xml_diff>
--- a/04-proposal/figures/proposal-figures.pptx
+++ b/04-proposal/figures/proposal-figures.pptx
@@ -6279,460 +6279,13 @@
       </p:sp>
       <p:sp>
         <p:nvSpPr>
-          <p:cNvPr id="47" name="Text 45"/>
-          <p:cNvSpPr/>
-          <p:nvPr/>
-        </p:nvSpPr>
-        <p:spPr>
-          <a:xfrm>
-            <a:off x="304800" y="3471416"/>
-            <a:ext cx="2777133" cy="479227"/>
-          </a:xfrm>
-          <a:prstGeom prst="rect">
-            <a:avLst/>
-          </a:prstGeom>
-          <a:noFill/>
-          <a:ln w="9525">
-            <a:solidFill>
-              <a:srgbClr val="CCCCCC"/>
-            </a:solidFill>
-          </a:ln>
-        </p:spPr>
-        <p:txBody>
-          <a:bodyPr wrap="square" rtlCol="0" anchor="ctr"/>
-          <a:lstStyle/>
-          <a:p>
-            <a:pPr indent="0" marL="0">
-              <a:buNone/>
-            </a:pPr>
-            <a:endParaRPr lang="en-US" dirty="0"/>
-          </a:p>
-        </p:txBody>
-      </p:sp>
-      <p:sp>
-        <p:nvSpPr>
-          <p:cNvPr id="48" name="Text 46"/>
-          <p:cNvSpPr/>
-          <p:nvPr/>
-        </p:nvSpPr>
-        <p:spPr>
-          <a:xfrm>
-            <a:off x="415826" y="3544342"/>
-            <a:ext cx="2606183" cy="123825"/>
-          </a:xfrm>
-          <a:prstGeom prst="rect">
-            <a:avLst/>
-          </a:prstGeom>
-          <a:noFill/>
-          <a:ln/>
-        </p:spPr>
-        <p:txBody>
-          <a:bodyPr wrap="square" lIns="0" tIns="0" rIns="0" bIns="0" rtlCol="0" anchor="t"/>
-          <a:lstStyle/>
-          <a:p>
-            <a:pPr algn="l" indent="0" marL="0">
-              <a:buNone/>
-            </a:pPr>
-            <a:r>
-              <a:rPr lang="en-US" sz="800" b="1" dirty="0">
-                <a:solidFill>
-                  <a:srgbClr val="333333"/>
-                </a:solidFill>
-                <a:latin typeface="Malgun Gothic" pitchFamily="34" charset="0"/>
-                <a:ea typeface="Malgun Gothic" pitchFamily="34" charset="-122"/>
-                <a:cs typeface="Malgun Gothic" pitchFamily="34" charset="-120"/>
-              </a:rPr>
-              <a:t>기아 방지</a:t>
-            </a:r>
-            <a:endParaRPr lang="en-US" sz="800" dirty="0"/>
-          </a:p>
-        </p:txBody>
-      </p:sp>
-      <p:sp>
-        <p:nvSpPr>
-          <p:cNvPr id="49" name="Text 47"/>
-          <p:cNvSpPr/>
-          <p:nvPr/>
-        </p:nvSpPr>
-        <p:spPr>
-          <a:xfrm>
-            <a:off x="415826" y="3668167"/>
-            <a:ext cx="2606183" cy="104775"/>
-          </a:xfrm>
-          <a:prstGeom prst="rect">
-            <a:avLst/>
-          </a:prstGeom>
-          <a:noFill/>
-          <a:ln/>
-        </p:spPr>
-        <p:txBody>
-          <a:bodyPr wrap="square" lIns="0" tIns="0" rIns="0" bIns="0" rtlCol="0" anchor="t"/>
-          <a:lstStyle/>
-          <a:p>
-            <a:pPr algn="l" indent="0" marL="0">
-              <a:buNone/>
-            </a:pPr>
-            <a:r>
-              <a:rPr lang="en-US" sz="700" dirty="0">
-                <a:solidFill>
-                  <a:srgbClr val="666666"/>
-                </a:solidFill>
-                <a:latin typeface="Malgun Gothic" pitchFamily="34" charset="0"/>
-                <a:ea typeface="Malgun Gothic" pitchFamily="34" charset="-122"/>
-                <a:cs typeface="Malgun Gothic" pitchFamily="34" charset="-120"/>
-              </a:rPr>
-              <a:t>Priority: 에이징 (자동 승격)</a:t>
-            </a:r>
-            <a:endParaRPr lang="en-US" sz="700" dirty="0"/>
-          </a:p>
-        </p:txBody>
-      </p:sp>
-      <p:sp>
-        <p:nvSpPr>
-          <p:cNvPr id="50" name="Text 48"/>
-          <p:cNvSpPr/>
-          <p:nvPr/>
-        </p:nvSpPr>
-        <p:spPr>
-          <a:xfrm>
-            <a:off x="415826" y="3772942"/>
-            <a:ext cx="2606183" cy="104775"/>
-          </a:xfrm>
-          <a:prstGeom prst="rect">
-            <a:avLst/>
-          </a:prstGeom>
-          <a:noFill/>
-          <a:ln/>
-        </p:spPr>
-        <p:txBody>
-          <a:bodyPr wrap="square" lIns="0" tIns="0" rIns="0" bIns="0" rtlCol="0" anchor="t"/>
-          <a:lstStyle/>
-          <a:p>
-            <a:pPr algn="l" indent="0" marL="0">
-              <a:buNone/>
-            </a:pPr>
-            <a:r>
-              <a:rPr lang="en-US" sz="700" dirty="0">
-                <a:solidFill>
-                  <a:srgbClr val="666666"/>
-                </a:solidFill>
-                <a:latin typeface="Malgun Gothic" pitchFamily="34" charset="0"/>
-                <a:ea typeface="Malgun Gothic" pitchFamily="34" charset="-122"/>
-                <a:cs typeface="Malgun Gothic" pitchFamily="34" charset="-120"/>
-              </a:rPr>
-              <a:t>MLFQ: 주기적 부스트 (전체 → Q0)</a:t>
-            </a:r>
-            <a:endParaRPr lang="en-US" sz="700" dirty="0"/>
-          </a:p>
-        </p:txBody>
-      </p:sp>
-      <p:sp>
-        <p:nvSpPr>
-          <p:cNvPr id="51" name="Text 49"/>
-          <p:cNvSpPr/>
-          <p:nvPr/>
-        </p:nvSpPr>
-        <p:spPr>
-          <a:xfrm>
-            <a:off x="3183434" y="3471416"/>
-            <a:ext cx="2777133" cy="479227"/>
-          </a:xfrm>
-          <a:prstGeom prst="rect">
-            <a:avLst/>
-          </a:prstGeom>
-          <a:noFill/>
-          <a:ln w="9525">
-            <a:solidFill>
-              <a:srgbClr val="CCCCCC"/>
-            </a:solidFill>
-          </a:ln>
-        </p:spPr>
-        <p:txBody>
-          <a:bodyPr wrap="square" rtlCol="0" anchor="ctr"/>
-          <a:lstStyle/>
-          <a:p>
-            <a:pPr indent="0" marL="0">
-              <a:buNone/>
-            </a:pPr>
-            <a:endParaRPr lang="en-US" dirty="0"/>
-          </a:p>
-        </p:txBody>
-      </p:sp>
-      <p:sp>
-        <p:nvSpPr>
-          <p:cNvPr id="52" name="Text 50"/>
-          <p:cNvSpPr/>
-          <p:nvPr/>
-        </p:nvSpPr>
-        <p:spPr>
-          <a:xfrm>
-            <a:off x="3294459" y="3544342"/>
-            <a:ext cx="2606183" cy="123825"/>
-          </a:xfrm>
-          <a:prstGeom prst="rect">
-            <a:avLst/>
-          </a:prstGeom>
-          <a:noFill/>
-          <a:ln/>
-        </p:spPr>
-        <p:txBody>
-          <a:bodyPr wrap="square" lIns="0" tIns="0" rIns="0" bIns="0" rtlCol="0" anchor="t"/>
-          <a:lstStyle/>
-          <a:p>
-            <a:pPr algn="l" indent="0" marL="0">
-              <a:buNone/>
-            </a:pPr>
-            <a:r>
-              <a:rPr lang="en-US" sz="800" b="1" dirty="0">
-                <a:solidFill>
-                  <a:srgbClr val="333333"/>
-                </a:solidFill>
-                <a:latin typeface="Malgun Gothic" pitchFamily="34" charset="0"/>
-                <a:ea typeface="Malgun Gothic" pitchFamily="34" charset="-122"/>
-                <a:cs typeface="Malgun Gothic" pitchFamily="34" charset="-120"/>
-              </a:rPr>
-              <a:t>MLFQ 선점</a:t>
-            </a:r>
-            <a:endParaRPr lang="en-US" sz="800" dirty="0"/>
-          </a:p>
-        </p:txBody>
-      </p:sp>
-      <p:sp>
-        <p:nvSpPr>
-          <p:cNvPr id="53" name="Text 51"/>
-          <p:cNvSpPr/>
-          <p:nvPr/>
-        </p:nvSpPr>
-        <p:spPr>
-          <a:xfrm>
-            <a:off x="3294459" y="3668167"/>
-            <a:ext cx="2606183" cy="104775"/>
-          </a:xfrm>
-          <a:prstGeom prst="rect">
-            <a:avLst/>
-          </a:prstGeom>
-          <a:noFill/>
-          <a:ln/>
-        </p:spPr>
-        <p:txBody>
-          <a:bodyPr wrap="square" lIns="0" tIns="0" rIns="0" bIns="0" rtlCol="0" anchor="t"/>
-          <a:lstStyle/>
-          <a:p>
-            <a:pPr algn="l" indent="0" marL="0">
-              <a:buNone/>
-            </a:pPr>
-            <a:r>
-              <a:rPr lang="en-US" sz="700" dirty="0">
-                <a:solidFill>
-                  <a:srgbClr val="666666"/>
-                </a:solidFill>
-                <a:latin typeface="Malgun Gothic" pitchFamily="34" charset="0"/>
-                <a:ea typeface="Malgun Gothic" pitchFamily="34" charset="-122"/>
-                <a:cs typeface="Malgun Gothic" pitchFamily="34" charset="-120"/>
-              </a:rPr>
-              <a:t>시간 슬라이스: 500ms 확인 주기</a:t>
-            </a:r>
-            <a:endParaRPr lang="en-US" sz="700" dirty="0"/>
-          </a:p>
-        </p:txBody>
-      </p:sp>
-      <p:sp>
-        <p:nvSpPr>
-          <p:cNvPr id="54" name="Text 52"/>
-          <p:cNvSpPr/>
-          <p:nvPr/>
-        </p:nvSpPr>
-        <p:spPr>
-          <a:xfrm>
-            <a:off x="3294459" y="3772942"/>
-            <a:ext cx="2606183" cy="104775"/>
-          </a:xfrm>
-          <a:prstGeom prst="rect">
-            <a:avLst/>
-          </a:prstGeom>
-          <a:noFill/>
-          <a:ln/>
-        </p:spPr>
-        <p:txBody>
-          <a:bodyPr wrap="square" lIns="0" tIns="0" rIns="0" bIns="0" rtlCol="0" anchor="t"/>
-          <a:lstStyle/>
-          <a:p>
-            <a:pPr algn="l" indent="0" marL="0">
-              <a:buNone/>
-            </a:pPr>
-            <a:r>
-              <a:rPr lang="en-US" sz="700" dirty="0">
-                <a:solidFill>
-                  <a:srgbClr val="666666"/>
-                </a:solidFill>
-                <a:latin typeface="Malgun Gothic" pitchFamily="34" charset="0"/>
-                <a:ea typeface="Malgun Gothic" pitchFamily="34" charset="-122"/>
-                <a:cs typeface="Malgun Gothic" pitchFamily="34" charset="-120"/>
-              </a:rPr>
-              <a:t>퀀텀 초과 → 하위 큐로 이동</a:t>
-            </a:r>
-            <a:endParaRPr lang="en-US" sz="700" dirty="0"/>
-          </a:p>
-        </p:txBody>
-      </p:sp>
-      <p:sp>
-        <p:nvSpPr>
-          <p:cNvPr id="55" name="Text 53"/>
-          <p:cNvSpPr/>
-          <p:nvPr/>
-        </p:nvSpPr>
-        <p:spPr>
-          <a:xfrm>
-            <a:off x="6062067" y="3471416"/>
-            <a:ext cx="2777133" cy="479227"/>
-          </a:xfrm>
-          <a:prstGeom prst="rect">
-            <a:avLst/>
-          </a:prstGeom>
-          <a:noFill/>
-          <a:ln w="9525">
-            <a:solidFill>
-              <a:srgbClr val="CCCCCC"/>
-            </a:solidFill>
-          </a:ln>
-        </p:spPr>
-        <p:txBody>
-          <a:bodyPr wrap="square" rtlCol="0" anchor="ctr"/>
-          <a:lstStyle/>
-          <a:p>
-            <a:pPr indent="0" marL="0">
-              <a:buNone/>
-            </a:pPr>
-            <a:endParaRPr lang="en-US" dirty="0"/>
-          </a:p>
-        </p:txBody>
-      </p:sp>
-      <p:sp>
-        <p:nvSpPr>
-          <p:cNvPr id="56" name="Text 54"/>
-          <p:cNvSpPr/>
-          <p:nvPr/>
-        </p:nvSpPr>
-        <p:spPr>
-          <a:xfrm>
-            <a:off x="6173093" y="3544342"/>
-            <a:ext cx="2606183" cy="123825"/>
-          </a:xfrm>
-          <a:prstGeom prst="rect">
-            <a:avLst/>
-          </a:prstGeom>
-          <a:noFill/>
-          <a:ln/>
-        </p:spPr>
-        <p:txBody>
-          <a:bodyPr wrap="square" lIns="0" tIns="0" rIns="0" bIns="0" rtlCol="0" anchor="t"/>
-          <a:lstStyle/>
-          <a:p>
-            <a:pPr algn="l" indent="0" marL="0">
-              <a:buNone/>
-            </a:pPr>
-            <a:r>
-              <a:rPr lang="en-US" sz="800" b="1" dirty="0">
-                <a:solidFill>
-                  <a:srgbClr val="333333"/>
-                </a:solidFill>
-                <a:latin typeface="Malgun Gothic" pitchFamily="34" charset="0"/>
-                <a:ea typeface="Malgun Gothic" pitchFamily="34" charset="-122"/>
-                <a:cs typeface="Malgun Gothic" pitchFamily="34" charset="-120"/>
-              </a:rPr>
-              <a:t>이중 수준 공정성</a:t>
-            </a:r>
-            <a:endParaRPr lang="en-US" sz="800" dirty="0"/>
-          </a:p>
-        </p:txBody>
-      </p:sp>
-      <p:sp>
-        <p:nvSpPr>
-          <p:cNvPr id="57" name="Text 55"/>
-          <p:cNvSpPr/>
-          <p:nvPr/>
-        </p:nvSpPr>
-        <p:spPr>
-          <a:xfrm>
-            <a:off x="6173093" y="3668167"/>
-            <a:ext cx="2606183" cy="104775"/>
-          </a:xfrm>
-          <a:prstGeom prst="rect">
-            <a:avLst/>
-          </a:prstGeom>
-          <a:noFill/>
-          <a:ln/>
-        </p:spPr>
-        <p:txBody>
-          <a:bodyPr wrap="square" lIns="0" tIns="0" rIns="0" bIns="0" rtlCol="0" anchor="t"/>
-          <a:lstStyle/>
-          <a:p>
-            <a:pPr algn="l" indent="0" marL="0">
-              <a:buNone/>
-            </a:pPr>
-            <a:r>
-              <a:rPr lang="en-US" sz="700" dirty="0">
-                <a:solidFill>
-                  <a:srgbClr val="666666"/>
-                </a:solidFill>
-                <a:latin typeface="Malgun Gothic" pitchFamily="34" charset="0"/>
-                <a:ea typeface="Malgun Gothic" pitchFamily="34" charset="-122"/>
-                <a:cs typeface="Malgun Gothic" pitchFamily="34" charset="-120"/>
-              </a:rPr>
-              <a:t>시스템 JFI: 전체 테넌트 간</a:t>
-            </a:r>
-            <a:endParaRPr lang="en-US" sz="700" dirty="0"/>
-          </a:p>
-        </p:txBody>
-      </p:sp>
-      <p:sp>
-        <p:nvSpPr>
-          <p:cNvPr id="58" name="Text 56"/>
-          <p:cNvSpPr/>
-          <p:nvPr/>
-        </p:nvSpPr>
-        <p:spPr>
-          <a:xfrm>
-            <a:off x="6173093" y="3772942"/>
-            <a:ext cx="2606183" cy="104775"/>
-          </a:xfrm>
-          <a:prstGeom prst="rect">
-            <a:avLst/>
-          </a:prstGeom>
-          <a:noFill/>
-          <a:ln/>
-        </p:spPr>
-        <p:txBody>
-          <a:bodyPr wrap="square" lIns="0" tIns="0" rIns="0" bIns="0" rtlCol="0" anchor="t"/>
-          <a:lstStyle/>
-          <a:p>
-            <a:pPr algn="l" indent="0" marL="0">
-              <a:buNone/>
-            </a:pPr>
-            <a:r>
-              <a:rPr lang="en-US" sz="700" dirty="0">
-                <a:solidFill>
-                  <a:srgbClr val="666666"/>
-                </a:solidFill>
-                <a:latin typeface="Malgun Gothic" pitchFamily="34" charset="0"/>
-                <a:ea typeface="Malgun Gothic" pitchFamily="34" charset="-122"/>
-                <a:cs typeface="Malgun Gothic" pitchFamily="34" charset="-120"/>
-              </a:rPr>
-              <a:t>테넌트 JFI: 동일 등급 내 (0.92~0.98)</a:t>
-            </a:r>
-            <a:endParaRPr lang="en-US" sz="700" dirty="0"/>
-          </a:p>
-        </p:txBody>
-      </p:sp>
-      <p:sp>
-        <p:nvSpPr>
-          <p:cNvPr id="59" name="Shape 57"/>
-          <p:cNvSpPr/>
-          <p:nvPr/>
-        </p:nvSpPr>
-        <p:spPr>
-          <a:xfrm>
-            <a:off x="304800" y="4881711"/>
+          <p:cNvPr id="47" name="Shape 45"/>
+          <p:cNvSpPr/>
+          <p:nvPr/>
+        </p:nvSpPr>
+        <p:spPr>
+          <a:xfrm>
+            <a:off x="304800" y="4862661"/>
             <a:ext cx="8534400" cy="0"/>
           </a:xfrm>
           <a:prstGeom prst="line">
@@ -6749,14 +6302,14 @@
       </p:sp>
       <p:sp>
         <p:nvSpPr>
-          <p:cNvPr id="60" name="Text 58"/>
-          <p:cNvSpPr/>
-          <p:nvPr/>
-        </p:nvSpPr>
-        <p:spPr>
-          <a:xfrm>
-            <a:off x="304800" y="4937224"/>
-            <a:ext cx="8705088" cy="104775"/>
+          <p:cNvPr id="48" name="Text 46"/>
+          <p:cNvSpPr/>
+          <p:nvPr/>
+        </p:nvSpPr>
+        <p:spPr>
+          <a:xfrm>
+            <a:off x="304800" y="4918174"/>
+            <a:ext cx="8705088" cy="123825"/>
           </a:xfrm>
           <a:prstGeom prst="rect">
             <a:avLst/>
@@ -6772,7 +6325,7 @@
               <a:buNone/>
             </a:pPr>
             <a:r>
-              <a:rPr lang="en-US" sz="700" i="1" dirty="0">
+              <a:rPr lang="en-US" sz="750" i="1" dirty="0">
                 <a:solidFill>
                   <a:srgbClr val="999999"/>
                 </a:solidFill>
@@ -6780,9 +6333,9 @@
                 <a:ea typeface="Malgun Gothic" pitchFamily="34" charset="-122"/>
                 <a:cs typeface="Malgun Gothic" pitchFamily="34" charset="-120"/>
               </a:rPr>
-              <a:t>Node.js 22 LTS + Express.js 4.18 | 메모리 배열 + JSON 파일 | 307 tests, 99.76% coverage</a:t>
-            </a:r>
-            <a:endParaRPr lang="en-US" sz="700" dirty="0"/>
+              <a:t>핵심: 에이징/부스트로 기아 방지 · MLFQ 선점으로 짧은 요청 우선 · JFI로 공정성 측정</a:t>
+            </a:r>
+            <a:endParaRPr lang="en-US" sz="750" dirty="0"/>
           </a:p>
         </p:txBody>
       </p:sp>

</xml_diff>

<commit_message>
Refactor proposal document and update scheduling algorithm descriptions
- Updated the proposal document (proposal-v24.md) to clarify the limitations of current LLM services and the proposed scheduling algorithms.
- Enhanced descriptions of the MLFQ algorithm to reflect its non-preemptive nature and the feedback mechanism.
- Revised the explanation of the WFQ algorithm to emphasize its focus on proportional resource allocation based on tenant weights.
- Adjusted the figures in the presentation (proposal-figures.pptx) to align with the updated proposal content, including changes to algorithm descriptions and flow diagrams.
- Added a lessons learned document to capture insights from the proposal revision process, emphasizing the importance of logical consistency in academic writing.
</commit_message>
<xml_diff>
--- a/04-proposal/figures/proposal-figures.pptx
+++ b/04-proposal/figures/proposal-figures.pptx
@@ -2155,7 +2155,7 @@
                 <a:ea typeface="Malgun Gothic" pitchFamily="34" charset="-122"/>
                 <a:cs typeface="Malgun Gothic" pitchFamily="34" charset="-120"/>
               </a:rPr>
-              <a:t>선점형 스케줄링</a:t>
+              <a:t>비선점형 적응</a:t>
             </a:r>
             <a:endParaRPr lang="en-US" sz="950" dirty="0"/>
           </a:p>
@@ -5745,7 +5745,7 @@
                 <a:ea typeface="Malgun Gothic" pitchFamily="34" charset="-122"/>
                 <a:cs typeface="Malgun Gothic" pitchFamily="34" charset="-120"/>
               </a:rPr>
-              <a:t>4단계 큐 + 선점</a:t>
+              <a:t>4단계 큐 + 완료 후 피드백</a:t>
             </a:r>
             <a:endParaRPr lang="en-US" sz="700" dirty="0"/>
           </a:p>
@@ -6567,7 +6567,7 @@
                 <a:ea typeface="Malgun Gothic" pitchFamily="34" charset="-122"/>
                 <a:cs typeface="Malgun Gothic" pitchFamily="34" charset="-120"/>
               </a:rPr>
-              <a:t>핵심: 에이징/부스트로 기아 방지 · MLFQ 선점으로 짧은 요청 우선 · JFI로 공정성 측정</a:t>
+              <a:t>핵심: 에이징/부스트로 기아 방지 · MLFQ 완료 후 피드백으로 적응형 분류 · JFI로 공정성 측정</a:t>
             </a:r>
             <a:endParaRPr lang="en-US" sz="750" dirty="0"/>
           </a:p>

</xml_diff>

<commit_message>
Add proposal for multi-user LLM API request management system using OS scheduling algorithms
- Introduced a new draft proposal (proposal-v25.md) detailing the research background, objectives, and proposed system architecture.
- Updated figures for algorithm comparison and request flow in the presentation slides.
- Modified HTML slides to reflect changes in algorithm features and limitations.
- Updated binary files for figures and final proposal document.
</commit_message>
<xml_diff>
--- a/04-proposal/figures/proposal-figures.pptx
+++ b/04-proposal/figures/proposal-figures.pptx
@@ -1703,7 +1703,7 @@
         <p:spPr>
           <a:xfrm>
             <a:off x="2644676" y="1596479"/>
-            <a:ext cx="1727448" cy="600075"/>
+            <a:ext cx="1727448" cy="304800"/>
           </a:xfrm>
           <a:prstGeom prst="rect">
             <a:avLst/>
@@ -1728,7 +1728,7 @@
                 <a:ea typeface="Malgun Gothic" pitchFamily="34" charset="-122"/>
                 <a:cs typeface="Malgun Gothic" pitchFamily="34" charset="-120"/>
               </a:rPr>
-              <a:t>4단계 우선순위 (URGENT~LOW)</a:t>
+              <a:t>등급/긴급도 기반 우선순위</a:t>
             </a:r>
             <a:endParaRPr lang="en-US" sz="950" dirty="0"/>
           </a:p>
@@ -1750,24 +1750,6 @@
             </a:r>
             <a:endParaRPr lang="en-US" sz="950" dirty="0"/>
           </a:p>
-          <a:p>
-            <a:pPr algn="l" marL="88900" indent="-88900">
-              <a:buSzPct val="100000"/>
-              <a:buChar char="•"/>
-            </a:pPr>
-            <a:r>
-              <a:rPr lang="en-US" sz="950" dirty="0">
-                <a:solidFill>
-                  <a:srgbClr val="333333"/>
-                </a:solidFill>
-                <a:latin typeface="Malgun Gothic" pitchFamily="34" charset="0"/>
-                <a:ea typeface="Malgun Gothic" pitchFamily="34" charset="-122"/>
-                <a:cs typeface="Malgun Gothic" pitchFamily="34" charset="-120"/>
-              </a:rPr>
-              <a:t>동적 우선순위 조정</a:t>
-            </a:r>
-            <a:endParaRPr lang="en-US" sz="950" dirty="0"/>
-          </a:p>
         </p:txBody>
       </p:sp>
       <p:sp>
@@ -1778,7 +1760,7 @@
         </p:nvSpPr>
         <p:spPr>
           <a:xfrm>
-            <a:off x="2644676" y="2518618"/>
+            <a:off x="2644676" y="2223343"/>
             <a:ext cx="1727448" cy="0"/>
           </a:xfrm>
           <a:prstGeom prst="line">
@@ -1801,7 +1783,7 @@
         </p:nvSpPr>
         <p:spPr>
           <a:xfrm>
-            <a:off x="2644676" y="2323356"/>
+            <a:off x="2644676" y="2028081"/>
             <a:ext cx="1761997" cy="152400"/>
           </a:xfrm>
           <a:prstGeom prst="rect">
@@ -1840,7 +1822,7 @@
         </p:nvSpPr>
         <p:spPr>
           <a:xfrm>
-            <a:off x="2644676" y="2612082"/>
+            <a:off x="2644676" y="2316807"/>
             <a:ext cx="1761997" cy="152400"/>
           </a:xfrm>
           <a:prstGeom prst="rect">
@@ -2094,7 +2076,7 @@
         <p:spPr>
           <a:xfrm>
             <a:off x="4772025" y="1596479"/>
-            <a:ext cx="1727299" cy="457200"/>
+            <a:ext cx="1727299" cy="304800"/>
           </a:xfrm>
           <a:prstGeom prst="rect">
             <a:avLst/>
@@ -2119,7 +2101,7 @@
                 <a:ea typeface="Malgun Gothic" pitchFamily="34" charset="-122"/>
                 <a:cs typeface="Malgun Gothic" pitchFamily="34" charset="-120"/>
               </a:rPr>
-              <a:t>적응형 분류</a:t>
+              <a:t>실행 특성 관찰 후 분류</a:t>
             </a:r>
             <a:endParaRPr lang="en-US" sz="950" dirty="0"/>
           </a:p>
@@ -2137,28 +2119,10 @@
                 <a:ea typeface="Malgun Gothic" pitchFamily="34" charset="-122"/>
                 <a:cs typeface="Malgun Gothic" pitchFamily="34" charset="-120"/>
               </a:rPr>
-              <a:t>큐별 타임 퀀텀</a:t>
+              <a:t>다단계 큐 구조</a:t>
             </a:r>
             <a:endParaRPr lang="en-US" sz="950" dirty="0"/>
           </a:p>
-          <a:p>
-            <a:pPr algn="l" marL="88900" indent="-88900">
-              <a:buSzPct val="100000"/>
-              <a:buChar char="•"/>
-            </a:pPr>
-            <a:r>
-              <a:rPr lang="en-US" sz="950" dirty="0">
-                <a:solidFill>
-                  <a:srgbClr val="333333"/>
-                </a:solidFill>
-                <a:latin typeface="Malgun Gothic" pitchFamily="34" charset="0"/>
-                <a:ea typeface="Malgun Gothic" pitchFamily="34" charset="-122"/>
-                <a:cs typeface="Malgun Gothic" pitchFamily="34" charset="-120"/>
-              </a:rPr>
-              <a:t>비선점형 적응</a:t>
-            </a:r>
-            <a:endParaRPr lang="en-US" sz="950" dirty="0"/>
-          </a:p>
         </p:txBody>
       </p:sp>
       <p:sp>
@@ -2169,7 +2133,7 @@
         </p:nvSpPr>
         <p:spPr>
           <a:xfrm>
-            <a:off x="4772025" y="2375743"/>
+            <a:off x="4772025" y="2223343"/>
             <a:ext cx="1727299" cy="0"/>
           </a:xfrm>
           <a:prstGeom prst="line">
@@ -2192,7 +2156,7 @@
         </p:nvSpPr>
         <p:spPr>
           <a:xfrm>
-            <a:off x="4772025" y="2180481"/>
+            <a:off x="4772025" y="2028081"/>
             <a:ext cx="1761845" cy="152400"/>
           </a:xfrm>
           <a:prstGeom prst="rect">
@@ -2231,7 +2195,7 @@
         </p:nvSpPr>
         <p:spPr>
           <a:xfrm>
-            <a:off x="4772025" y="2469207"/>
+            <a:off x="4772025" y="2316807"/>
             <a:ext cx="1761845" cy="152400"/>
           </a:xfrm>
           <a:prstGeom prst="rect">
@@ -2485,7 +2449,7 @@
         <p:spPr>
           <a:xfrm>
             <a:off x="6899225" y="1596479"/>
-            <a:ext cx="1727299" cy="457200"/>
+            <a:ext cx="1727299" cy="304800"/>
           </a:xfrm>
           <a:prstGeom prst="rect">
             <a:avLst/>
@@ -2510,7 +2474,7 @@
                 <a:ea typeface="Malgun Gothic" pitchFamily="34" charset="-122"/>
                 <a:cs typeface="Malgun Gothic" pitchFamily="34" charset="-120"/>
               </a:rPr>
-              <a:t>가중치 비례 서비스</a:t>
+              <a:t>등급별 가중치 비례 배분</a:t>
             </a:r>
             <a:endParaRPr lang="en-US" sz="950" dirty="0"/>
           </a:p>
@@ -2528,28 +2492,10 @@
                 <a:ea typeface="Malgun Gothic" pitchFamily="34" charset="-122"/>
                 <a:cs typeface="Malgun Gothic" pitchFamily="34" charset="-120"/>
               </a:rPr>
-              <a:t>가상 종료 시각 계산</a:t>
+              <a:t>공정성 지표(JFI) 측정</a:t>
             </a:r>
             <a:endParaRPr lang="en-US" sz="950" dirty="0"/>
           </a:p>
-          <a:p>
-            <a:pPr algn="l" marL="88900" indent="-88900">
-              <a:buSzPct val="100000"/>
-              <a:buChar char="•"/>
-            </a:pPr>
-            <a:r>
-              <a:rPr lang="en-US" sz="950" dirty="0">
-                <a:solidFill>
-                  <a:srgbClr val="333333"/>
-                </a:solidFill>
-                <a:latin typeface="Malgun Gothic" pitchFamily="34" charset="0"/>
-                <a:ea typeface="Malgun Gothic" pitchFamily="34" charset="-122"/>
-                <a:cs typeface="Malgun Gothic" pitchFamily="34" charset="-120"/>
-              </a:rPr>
-              <a:t>JFI 공정성 지표</a:t>
-            </a:r>
-            <a:endParaRPr lang="en-US" sz="950" dirty="0"/>
-          </a:p>
         </p:txBody>
       </p:sp>
       <p:sp>
@@ -2560,7 +2506,7 @@
         </p:nvSpPr>
         <p:spPr>
           <a:xfrm>
-            <a:off x="6899225" y="2375743"/>
+            <a:off x="6899225" y="2223343"/>
             <a:ext cx="1727299" cy="0"/>
           </a:xfrm>
           <a:prstGeom prst="line">
@@ -2583,7 +2529,7 @@
         </p:nvSpPr>
         <p:spPr>
           <a:xfrm>
-            <a:off x="6899225" y="2180481"/>
+            <a:off x="6899225" y="2028081"/>
             <a:ext cx="1761845" cy="152400"/>
           </a:xfrm>
           <a:prstGeom prst="rect">
@@ -2622,7 +2568,7 @@
         </p:nvSpPr>
         <p:spPr>
           <a:xfrm>
-            <a:off x="6899225" y="2469207"/>
+            <a:off x="6899225" y="2316807"/>
             <a:ext cx="1761845" cy="152400"/>
           </a:xfrm>
           <a:prstGeom prst="rect">
@@ -2653,7 +2599,7 @@
                 <a:ea typeface="Malgun Gothic" pitchFamily="34" charset="-122"/>
                 <a:cs typeface="Malgun Gothic" pitchFamily="34" charset="-120"/>
               </a:rPr>
-              <a:t>VFT 계산 부담</a:t>
+              <a:t>스케줄링 계산 부담</a:t>
             </a:r>
             <a:endParaRPr lang="en-US" sz="950" dirty="0"/>
           </a:p>
@@ -5424,7 +5370,7 @@
         <p:spPr>
           <a:xfrm>
             <a:off x="304800" y="1668959"/>
-            <a:ext cx="2076450" cy="647700"/>
+            <a:ext cx="2076450" cy="447675"/>
           </a:xfrm>
           <a:prstGeom prst="rect">
             <a:avLst/>
@@ -5457,7 +5403,7 @@
         </p:nvSpPr>
         <p:spPr>
           <a:xfrm>
-            <a:off x="397282" y="1854696"/>
+            <a:off x="397282" y="1754684"/>
             <a:ext cx="1891486" cy="142875"/>
           </a:xfrm>
           <a:prstGeom prst="rect">
@@ -5496,7 +5442,7 @@
         </p:nvSpPr>
         <p:spPr>
           <a:xfrm>
-            <a:off x="397282" y="1997571"/>
+            <a:off x="397282" y="1897559"/>
             <a:ext cx="1891486" cy="133350"/>
           </a:xfrm>
           <a:prstGeom prst="rect">
@@ -5536,7 +5482,7 @@
         <p:spPr>
           <a:xfrm>
             <a:off x="2457450" y="1668959"/>
-            <a:ext cx="2076450" cy="647700"/>
+            <a:ext cx="2076450" cy="447675"/>
           </a:xfrm>
           <a:prstGeom prst="rect">
             <a:avLst/>
@@ -5569,7 +5515,7 @@
         </p:nvSpPr>
         <p:spPr>
           <a:xfrm>
-            <a:off x="2549932" y="1854696"/>
+            <a:off x="2549932" y="1754684"/>
             <a:ext cx="1891486" cy="142875"/>
           </a:xfrm>
           <a:prstGeom prst="rect">
@@ -5608,7 +5554,7 @@
         </p:nvSpPr>
         <p:spPr>
           <a:xfrm>
-            <a:off x="2549932" y="1997571"/>
+            <a:off x="2549932" y="1897559"/>
             <a:ext cx="1891486" cy="133350"/>
           </a:xfrm>
           <a:prstGeom prst="rect">
@@ -5648,7 +5594,7 @@
         <p:spPr>
           <a:xfrm>
             <a:off x="4610100" y="1668959"/>
-            <a:ext cx="2076450" cy="647700"/>
+            <a:ext cx="2076450" cy="447675"/>
           </a:xfrm>
           <a:prstGeom prst="rect">
             <a:avLst/>
@@ -5681,7 +5627,7 @@
         </p:nvSpPr>
         <p:spPr>
           <a:xfrm>
-            <a:off x="4702582" y="1754684"/>
+            <a:off x="4702582" y="1764209"/>
             <a:ext cx="1891486" cy="133350"/>
           </a:xfrm>
           <a:prstGeom prst="rect">
@@ -5720,8 +5666,8 @@
         </p:nvSpPr>
         <p:spPr>
           <a:xfrm>
-            <a:off x="4702582" y="1888034"/>
-            <a:ext cx="1891486" cy="104775"/>
+            <a:off x="4702582" y="1897559"/>
+            <a:ext cx="1891486" cy="123825"/>
           </a:xfrm>
           <a:prstGeom prst="rect">
             <a:avLst/>
@@ -5737,7 +5683,7 @@
               <a:buNone/>
             </a:pPr>
             <a:r>
-              <a:rPr lang="en-US" sz="700" dirty="0">
+              <a:rPr lang="en-US" sz="800" dirty="0">
                 <a:solidFill>
                   <a:srgbClr val="555555"/>
                 </a:solidFill>
@@ -5745,9 +5691,9 @@
                 <a:ea typeface="Malgun Gothic" pitchFamily="34" charset="-122"/>
                 <a:cs typeface="Malgun Gothic" pitchFamily="34" charset="-120"/>
               </a:rPr>
-              <a:t>4단계 큐 + 완료 후 피드백</a:t>
-            </a:r>
-            <a:endParaRPr lang="en-US" sz="700" dirty="0"/>
+              <a:t>다단계 큐 + 피드백</a:t>
+            </a:r>
+            <a:endParaRPr lang="en-US" sz="800" dirty="0"/>
           </a:p>
         </p:txBody>
       </p:sp>
@@ -5759,47 +5705,8 @@
         </p:nvSpPr>
         <p:spPr>
           <a:xfrm>
-            <a:off x="4702582" y="1992809"/>
-            <a:ext cx="1891486" cy="238125"/>
-          </a:xfrm>
-          <a:prstGeom prst="rect">
-            <a:avLst/>
-          </a:prstGeom>
-          <a:noFill/>
-          <a:ln/>
-        </p:spPr>
-        <p:txBody>
-          <a:bodyPr wrap="square" lIns="0" tIns="0" rIns="0" bIns="0" rtlCol="0" anchor="t"/>
-          <a:lstStyle/>
-          <a:p>
-            <a:pPr algn="ctr" indent="0" marL="0">
-              <a:buNone/>
-            </a:pPr>
-            <a:r>
-              <a:rPr lang="en-US" sz="800" i="1" dirty="0">
-                <a:solidFill>
-                  <a:srgbClr val="888888"/>
-                </a:solidFill>
-                <a:latin typeface="Malgun Gothic" pitchFamily="34" charset="0"/>
-                <a:ea typeface="Malgun Gothic" pitchFamily="34" charset="-122"/>
-                <a:cs typeface="Malgun Gothic" pitchFamily="34" charset="-120"/>
-              </a:rPr>
-              <a:t>Q0:1,000ms Q1:3,000ms Q2:8,000ms Q3:무제한</a:t>
-            </a:r>
-            <a:endParaRPr lang="en-US" sz="800" dirty="0"/>
-          </a:p>
-        </p:txBody>
-      </p:sp>
-      <p:sp>
-        <p:nvSpPr>
-          <p:cNvPr id="28" name="Text 26"/>
-          <p:cNvSpPr/>
-          <p:nvPr/>
-        </p:nvSpPr>
-        <p:spPr>
-          <a:xfrm>
             <a:off x="6762750" y="1668959"/>
-            <a:ext cx="2076450" cy="647700"/>
+            <a:ext cx="2076450" cy="447675"/>
           </a:xfrm>
           <a:prstGeom prst="rect">
             <a:avLst/>
@@ -5826,14 +5733,53 @@
       </p:sp>
       <p:sp>
         <p:nvSpPr>
+          <p:cNvPr id="28" name="Text 26"/>
+          <p:cNvSpPr/>
+          <p:nvPr/>
+        </p:nvSpPr>
+        <p:spPr>
+          <a:xfrm>
+            <a:off x="6855232" y="1764209"/>
+            <a:ext cx="1891486" cy="133350"/>
+          </a:xfrm>
+          <a:prstGeom prst="rect">
+            <a:avLst/>
+          </a:prstGeom>
+          <a:noFill/>
+          <a:ln/>
+        </p:spPr>
+        <p:txBody>
+          <a:bodyPr wrap="square" lIns="0" tIns="0" rIns="0" bIns="0" rtlCol="0" anchor="t"/>
+          <a:lstStyle/>
+          <a:p>
+            <a:pPr algn="ctr" indent="0" marL="0">
+              <a:buNone/>
+            </a:pPr>
+            <a:r>
+              <a:rPr lang="en-US" sz="900" b="1" dirty="0">
+                <a:solidFill>
+                  <a:srgbClr val="2B579A"/>
+                </a:solidFill>
+                <a:latin typeface="Malgun Gothic" pitchFamily="34" charset="0"/>
+                <a:ea typeface="Malgun Gothic" pitchFamily="34" charset="-122"/>
+                <a:cs typeface="Malgun Gothic" pitchFamily="34" charset="-120"/>
+              </a:rPr>
+              <a:t>WFQ</a:t>
+            </a:r>
+            <a:endParaRPr lang="en-US" sz="900" dirty="0"/>
+          </a:p>
+        </p:txBody>
+      </p:sp>
+      <p:sp>
+        <p:nvSpPr>
           <p:cNvPr id="29" name="Text 27"/>
           <p:cNvSpPr/>
           <p:nvPr/>
         </p:nvSpPr>
         <p:spPr>
           <a:xfrm>
-            <a:off x="6855232" y="1811834"/>
-            <a:ext cx="1891486" cy="133350"/>
+            <a:off x="6855232" y="1897559"/>
+            <a:ext cx="1891486" cy="123825"/>
           </a:xfrm>
           <a:prstGeom prst="rect">
             <a:avLst/>
@@ -5849,15 +5795,132 @@
               <a:buNone/>
             </a:pPr>
             <a:r>
+              <a:rPr lang="en-US" sz="800" dirty="0">
+                <a:solidFill>
+                  <a:srgbClr val="555555"/>
+                </a:solidFill>
+                <a:latin typeface="Malgun Gothic" pitchFamily="34" charset="0"/>
+                <a:ea typeface="Malgun Gothic" pitchFamily="34" charset="-122"/>
+                <a:cs typeface="Malgun Gothic" pitchFamily="34" charset="-120"/>
+              </a:rPr>
+              <a:t>가중치 비례 배분</a:t>
+            </a:r>
+            <a:endParaRPr lang="en-US" sz="800" dirty="0"/>
+          </a:p>
+        </p:txBody>
+      </p:sp>
+      <p:sp>
+        <p:nvSpPr>
+          <p:cNvPr id="30" name="Text 28"/>
+          <p:cNvSpPr/>
+          <p:nvPr/>
+        </p:nvSpPr>
+        <p:spPr>
+          <a:xfrm>
+            <a:off x="3313212" y="2154585"/>
+            <a:ext cx="2567928" cy="123825"/>
+          </a:xfrm>
+          <a:prstGeom prst="rect">
+            <a:avLst/>
+          </a:prstGeom>
+          <a:noFill/>
+          <a:ln/>
+        </p:spPr>
+        <p:txBody>
+          <a:bodyPr wrap="square" lIns="0" tIns="0" rIns="0" bIns="0" rtlCol="0" anchor="t"/>
+          <a:lstStyle/>
+          <a:p>
+            <a:pPr algn="l" indent="0" marL="0">
+              <a:buNone/>
+            </a:pPr>
+            <a:r>
+              <a:rPr lang="en-US" sz="800" i="1" dirty="0">
+                <a:solidFill>
+                  <a:srgbClr val="999999"/>
+                </a:solidFill>
+                <a:latin typeface="Malgun Gothic" pitchFamily="34" charset="0"/>
+                <a:ea typeface="Malgun Gothic" pitchFamily="34" charset="-122"/>
+                <a:cs typeface="Malgun Gothic" pitchFamily="34" charset="-120"/>
+              </a:rPr>
+              <a:t>PUT /api/scheduler → 런타임 알고리즘 전환 (재시작 불필요)</a:t>
+            </a:r>
+            <a:endParaRPr lang="en-US" sz="800" dirty="0"/>
+          </a:p>
+        </p:txBody>
+      </p:sp>
+      <p:sp>
+        <p:nvSpPr>
+          <p:cNvPr id="31" name="Text 29"/>
+          <p:cNvSpPr/>
+          <p:nvPr/>
+        </p:nvSpPr>
+        <p:spPr>
+          <a:xfrm>
+            <a:off x="4497288" y="2316361"/>
+            <a:ext cx="152412" cy="180975"/>
+          </a:xfrm>
+          <a:prstGeom prst="rect">
+            <a:avLst/>
+          </a:prstGeom>
+          <a:noFill/>
+          <a:ln/>
+        </p:spPr>
+        <p:txBody>
+          <a:bodyPr wrap="square" lIns="0" tIns="0" rIns="0" bIns="0" rtlCol="0" anchor="t"/>
+          <a:lstStyle/>
+          <a:p>
+            <a:pPr algn="l" indent="0" marL="0">
+              <a:buNone/>
+            </a:pPr>
+            <a:r>
+              <a:rPr lang="en-US" sz="1200" dirty="0">
+                <a:solidFill>
+                  <a:srgbClr val="888888"/>
+                </a:solidFill>
+                <a:latin typeface="Malgun Gothic" pitchFamily="34" charset="0"/>
+                <a:ea typeface="Malgun Gothic" pitchFamily="34" charset="-122"/>
+                <a:cs typeface="Malgun Gothic" pitchFamily="34" charset="-120"/>
+              </a:rPr>
+              <a:t>▼</a:t>
+            </a:r>
+            <a:endParaRPr lang="en-US" sz="1200" dirty="0"/>
+          </a:p>
+        </p:txBody>
+      </p:sp>
+      <p:sp>
+        <p:nvSpPr>
+          <p:cNvPr id="32" name="Text 30"/>
+          <p:cNvSpPr/>
+          <p:nvPr/>
+        </p:nvSpPr>
+        <p:spPr>
+          <a:xfrm>
+            <a:off x="406301" y="2547938"/>
+            <a:ext cx="8498026" cy="142875"/>
+          </a:xfrm>
+          <a:prstGeom prst="rect">
+            <a:avLst/>
+          </a:prstGeom>
+          <a:noFill/>
+          <a:ln/>
+        </p:spPr>
+        <p:txBody>
+          <a:bodyPr wrap="square" lIns="0" tIns="0" rIns="0" bIns="0" rtlCol="0" anchor="t"/>
+          <a:lstStyle/>
+          <a:p>
+            <a:pPr algn="l" indent="0" marL="0">
+              <a:buNone/>
+            </a:pPr>
+            <a:r>
               <a:rPr lang="en-US" sz="900" b="1" dirty="0">
                 <a:solidFill>
-                  <a:srgbClr val="2B579A"/>
-                </a:solidFill>
-                <a:latin typeface="Malgun Gothic" pitchFamily="34" charset="0"/>
-                <a:ea typeface="Malgun Gothic" pitchFamily="34" charset="-122"/>
-                <a:cs typeface="Malgun Gothic" pitchFamily="34" charset="-120"/>
-              </a:rPr>
-              <a:t>WFQ</a:t>
+                  <a:srgbClr val="888888"/>
+                </a:solidFill>
+                <a:latin typeface="Malgun Gothic" pitchFamily="34" charset="0"/>
+                <a:ea typeface="Malgun Gothic" pitchFamily="34" charset="-122"/>
+                <a:cs typeface="Malgun Gothic" pitchFamily="34" charset="-120"/>
+              </a:rPr>
+              <a:t>단계 3: 실행 및 응답</a:t>
             </a:r>
             <a:endParaRPr lang="en-US" sz="900" dirty="0"/>
           </a:p>
@@ -5865,208 +5928,13 @@
       </p:sp>
       <p:sp>
         <p:nvSpPr>
-          <p:cNvPr id="30" name="Text 28"/>
-          <p:cNvSpPr/>
-          <p:nvPr/>
-        </p:nvSpPr>
-        <p:spPr>
-          <a:xfrm>
-            <a:off x="6855232" y="1945184"/>
-            <a:ext cx="1891486" cy="104775"/>
-          </a:xfrm>
-          <a:prstGeom prst="rect">
-            <a:avLst/>
-          </a:prstGeom>
-          <a:noFill/>
-          <a:ln/>
-        </p:spPr>
-        <p:txBody>
-          <a:bodyPr wrap="square" lIns="0" tIns="0" rIns="0" bIns="0" rtlCol="0" anchor="t"/>
-          <a:lstStyle/>
-          <a:p>
-            <a:pPr algn="ctr" indent="0" marL="0">
-              <a:buNone/>
-            </a:pPr>
-            <a:r>
-              <a:rPr lang="en-US" sz="700" dirty="0">
-                <a:solidFill>
-                  <a:srgbClr val="555555"/>
-                </a:solidFill>
-                <a:latin typeface="Malgun Gothic" pitchFamily="34" charset="0"/>
-                <a:ea typeface="Malgun Gothic" pitchFamily="34" charset="-122"/>
-                <a:cs typeface="Malgun Gothic" pitchFamily="34" charset="-120"/>
-              </a:rPr>
-              <a:t>가상 종료 시각</a:t>
-            </a:r>
-            <a:endParaRPr lang="en-US" sz="700" dirty="0"/>
-          </a:p>
-        </p:txBody>
-      </p:sp>
-      <p:sp>
-        <p:nvSpPr>
-          <p:cNvPr id="31" name="Text 29"/>
-          <p:cNvSpPr/>
-          <p:nvPr/>
-        </p:nvSpPr>
-        <p:spPr>
-          <a:xfrm>
-            <a:off x="6855232" y="2049959"/>
-            <a:ext cx="1891486" cy="123825"/>
-          </a:xfrm>
-          <a:prstGeom prst="rect">
-            <a:avLst/>
-          </a:prstGeom>
-          <a:noFill/>
-          <a:ln/>
-        </p:spPr>
-        <p:txBody>
-          <a:bodyPr wrap="square" lIns="0" tIns="0" rIns="0" bIns="0" rtlCol="0" anchor="t"/>
-          <a:lstStyle/>
-          <a:p>
-            <a:pPr algn="ctr" indent="0" marL="0">
-              <a:buNone/>
-            </a:pPr>
-            <a:r>
-              <a:rPr lang="en-US" sz="800" i="1" dirty="0">
-                <a:solidFill>
-                  <a:srgbClr val="888888"/>
-                </a:solidFill>
-                <a:latin typeface="Malgun Gothic" pitchFamily="34" charset="0"/>
-                <a:ea typeface="Malgun Gothic" pitchFamily="34" charset="-122"/>
-                <a:cs typeface="Malgun Gothic" pitchFamily="34" charset="-120"/>
-              </a:rPr>
-              <a:t>가중치: 100/50/10/1</a:t>
-            </a:r>
-            <a:endParaRPr lang="en-US" sz="800" dirty="0"/>
-          </a:p>
-        </p:txBody>
-      </p:sp>
-      <p:sp>
-        <p:nvSpPr>
-          <p:cNvPr id="32" name="Text 30"/>
-          <p:cNvSpPr/>
-          <p:nvPr/>
-        </p:nvSpPr>
-        <p:spPr>
-          <a:xfrm>
-            <a:off x="3313212" y="2354610"/>
-            <a:ext cx="2567928" cy="123825"/>
-          </a:xfrm>
-          <a:prstGeom prst="rect">
-            <a:avLst/>
-          </a:prstGeom>
-          <a:noFill/>
-          <a:ln/>
-        </p:spPr>
-        <p:txBody>
-          <a:bodyPr wrap="square" lIns="0" tIns="0" rIns="0" bIns="0" rtlCol="0" anchor="t"/>
-          <a:lstStyle/>
-          <a:p>
-            <a:pPr algn="l" indent="0" marL="0">
-              <a:buNone/>
-            </a:pPr>
-            <a:r>
-              <a:rPr lang="en-US" sz="800" i="1" dirty="0">
-                <a:solidFill>
-                  <a:srgbClr val="999999"/>
-                </a:solidFill>
-                <a:latin typeface="Malgun Gothic" pitchFamily="34" charset="0"/>
-                <a:ea typeface="Malgun Gothic" pitchFamily="34" charset="-122"/>
-                <a:cs typeface="Malgun Gothic" pitchFamily="34" charset="-120"/>
-              </a:rPr>
-              <a:t>PUT /api/scheduler → 런타임 알고리즘 전환 (재시작 불필요)</a:t>
-            </a:r>
-            <a:endParaRPr lang="en-US" sz="800" dirty="0"/>
-          </a:p>
-        </p:txBody>
-      </p:sp>
-      <p:sp>
-        <p:nvSpPr>
           <p:cNvPr id="33" name="Text 31"/>
           <p:cNvSpPr/>
           <p:nvPr/>
         </p:nvSpPr>
         <p:spPr>
           <a:xfrm>
-            <a:off x="4497288" y="2516386"/>
-            <a:ext cx="152412" cy="180975"/>
-          </a:xfrm>
-          <a:prstGeom prst="rect">
-            <a:avLst/>
-          </a:prstGeom>
-          <a:noFill/>
-          <a:ln/>
-        </p:spPr>
-        <p:txBody>
-          <a:bodyPr wrap="square" lIns="0" tIns="0" rIns="0" bIns="0" rtlCol="0" anchor="t"/>
-          <a:lstStyle/>
-          <a:p>
-            <a:pPr algn="l" indent="0" marL="0">
-              <a:buNone/>
-            </a:pPr>
-            <a:r>
-              <a:rPr lang="en-US" sz="1200" dirty="0">
-                <a:solidFill>
-                  <a:srgbClr val="888888"/>
-                </a:solidFill>
-                <a:latin typeface="Malgun Gothic" pitchFamily="34" charset="0"/>
-                <a:ea typeface="Malgun Gothic" pitchFamily="34" charset="-122"/>
-                <a:cs typeface="Malgun Gothic" pitchFamily="34" charset="-120"/>
-              </a:rPr>
-              <a:t>▼</a:t>
-            </a:r>
-            <a:endParaRPr lang="en-US" sz="1200" dirty="0"/>
-          </a:p>
-        </p:txBody>
-      </p:sp>
-      <p:sp>
-        <p:nvSpPr>
-          <p:cNvPr id="34" name="Text 32"/>
-          <p:cNvSpPr/>
-          <p:nvPr/>
-        </p:nvSpPr>
-        <p:spPr>
-          <a:xfrm>
-            <a:off x="406301" y="2747963"/>
-            <a:ext cx="8498026" cy="142875"/>
-          </a:xfrm>
-          <a:prstGeom prst="rect">
-            <a:avLst/>
-          </a:prstGeom>
-          <a:noFill/>
-          <a:ln/>
-        </p:spPr>
-        <p:txBody>
-          <a:bodyPr wrap="square" lIns="0" tIns="0" rIns="0" bIns="0" rtlCol="0" anchor="t"/>
-          <a:lstStyle/>
-          <a:p>
-            <a:pPr algn="l" indent="0" marL="0">
-              <a:buNone/>
-            </a:pPr>
-            <a:r>
-              <a:rPr lang="en-US" sz="900" b="1" dirty="0">
-                <a:solidFill>
-                  <a:srgbClr val="888888"/>
-                </a:solidFill>
-                <a:latin typeface="Malgun Gothic" pitchFamily="34" charset="0"/>
-                <a:ea typeface="Malgun Gothic" pitchFamily="34" charset="-122"/>
-                <a:cs typeface="Malgun Gothic" pitchFamily="34" charset="-120"/>
-              </a:rPr>
-              <a:t>단계 3: 실행 및 응답</a:t>
-            </a:r>
-            <a:endParaRPr lang="en-US" sz="900" dirty="0"/>
-          </a:p>
-        </p:txBody>
-      </p:sp>
-      <p:sp>
-        <p:nvSpPr>
-          <p:cNvPr id="35" name="Text 33"/>
-          <p:cNvSpPr/>
-          <p:nvPr/>
-        </p:nvSpPr>
-        <p:spPr>
-          <a:xfrm>
-            <a:off x="304800" y="2966889"/>
+            <a:off x="304800" y="2766864"/>
             <a:ext cx="4749998" cy="679252"/>
           </a:xfrm>
           <a:prstGeom prst="rect">
@@ -6094,40 +5962,118 @@
       </p:sp>
       <p:sp>
         <p:nvSpPr>
+          <p:cNvPr id="34" name="Text 32"/>
+          <p:cNvSpPr/>
+          <p:nvPr/>
+        </p:nvSpPr>
+        <p:spPr>
+          <a:xfrm>
+            <a:off x="406220" y="2958852"/>
+            <a:ext cx="4547158" cy="152400"/>
+          </a:xfrm>
+          <a:prstGeom prst="rect">
+            <a:avLst/>
+          </a:prstGeom>
+          <a:noFill/>
+          <a:ln/>
+        </p:spPr>
+        <p:txBody>
+          <a:bodyPr wrap="square" lIns="0" tIns="0" rIns="0" bIns="0" rtlCol="0" anchor="t"/>
+          <a:lstStyle/>
+          <a:p>
+            <a:pPr algn="ctr" indent="0" marL="0">
+              <a:buNone/>
+            </a:pPr>
+            <a:r>
+              <a:rPr lang="en-US" sz="1000" b="1" dirty="0">
+                <a:solidFill>
+                  <a:srgbClr val="333333"/>
+                </a:solidFill>
+                <a:latin typeface="Malgun Gothic" pitchFamily="34" charset="0"/>
+                <a:ea typeface="Malgun Gothic" pitchFamily="34" charset="-122"/>
+                <a:cs typeface="Malgun Gothic" pitchFamily="34" charset="-120"/>
+              </a:rPr>
+              <a:t>스케줄러</a:t>
+            </a:r>
+            <a:endParaRPr lang="en-US" sz="1000" dirty="0"/>
+          </a:p>
+        </p:txBody>
+      </p:sp>
+      <p:sp>
+        <p:nvSpPr>
+          <p:cNvPr id="35" name="Text 33"/>
+          <p:cNvSpPr/>
+          <p:nvPr/>
+        </p:nvSpPr>
+        <p:spPr>
+          <a:xfrm>
+            <a:off x="406220" y="3111252"/>
+            <a:ext cx="4547158" cy="142875"/>
+          </a:xfrm>
+          <a:prstGeom prst="rect">
+            <a:avLst/>
+          </a:prstGeom>
+          <a:noFill/>
+          <a:ln/>
+        </p:spPr>
+        <p:txBody>
+          <a:bodyPr wrap="square" lIns="0" tIns="0" rIns="0" bIns="0" rtlCol="0" anchor="t"/>
+          <a:lstStyle/>
+          <a:p>
+            <a:pPr algn="ctr" indent="0" marL="0">
+              <a:buNone/>
+            </a:pPr>
+            <a:r>
+              <a:rPr lang="en-US" sz="900" dirty="0">
+                <a:solidFill>
+                  <a:srgbClr val="666666"/>
+                </a:solidFill>
+                <a:latin typeface="Malgun Gothic" pitchFamily="34" charset="0"/>
+                <a:ea typeface="Malgun Gothic" pitchFamily="34" charset="-122"/>
+                <a:cs typeface="Malgun Gothic" pitchFamily="34" charset="-120"/>
+              </a:rPr>
+              <a:t>다음 요청 추출 · LLM 백엔드로 전달</a:t>
+            </a:r>
+            <a:endParaRPr lang="en-US" sz="900" dirty="0"/>
+          </a:p>
+        </p:txBody>
+      </p:sp>
+      <p:sp>
+        <p:nvSpPr>
           <p:cNvPr id="36" name="Text 34"/>
           <p:cNvSpPr/>
           <p:nvPr/>
         </p:nvSpPr>
         <p:spPr>
           <a:xfrm>
-            <a:off x="406220" y="3158877"/>
-            <a:ext cx="4547158" cy="152400"/>
-          </a:xfrm>
-          <a:prstGeom prst="rect">
-            <a:avLst/>
-          </a:prstGeom>
-          <a:noFill/>
-          <a:ln/>
-        </p:spPr>
-        <p:txBody>
-          <a:bodyPr wrap="square" lIns="0" tIns="0" rIns="0" bIns="0" rtlCol="0" anchor="t"/>
-          <a:lstStyle/>
-          <a:p>
-            <a:pPr algn="ctr" indent="0" marL="0">
-              <a:buNone/>
-            </a:pPr>
-            <a:r>
-              <a:rPr lang="en-US" sz="1000" b="1" dirty="0">
-                <a:solidFill>
-                  <a:srgbClr val="333333"/>
-                </a:solidFill>
-                <a:latin typeface="Malgun Gothic" pitchFamily="34" charset="0"/>
-                <a:ea typeface="Malgun Gothic" pitchFamily="34" charset="-122"/>
-                <a:cs typeface="Malgun Gothic" pitchFamily="34" charset="-120"/>
-              </a:rPr>
-              <a:t>스케줄러</a:t>
-            </a:r>
-            <a:endParaRPr lang="en-US" sz="1000" dirty="0"/>
+            <a:off x="5130998" y="3001714"/>
+            <a:ext cx="181407" cy="209550"/>
+          </a:xfrm>
+          <a:prstGeom prst="rect">
+            <a:avLst/>
+          </a:prstGeom>
+          <a:noFill/>
+          <a:ln/>
+        </p:spPr>
+        <p:txBody>
+          <a:bodyPr wrap="square" lIns="0" tIns="0" rIns="0" bIns="0" rtlCol="0" anchor="t"/>
+          <a:lstStyle/>
+          <a:p>
+            <a:pPr algn="l" indent="0" marL="0">
+              <a:buNone/>
+            </a:pPr>
+            <a:r>
+              <a:rPr lang="en-US" sz="1400" dirty="0">
+                <a:solidFill>
+                  <a:srgbClr val="2B579A"/>
+                </a:solidFill>
+                <a:latin typeface="Malgun Gothic" pitchFamily="34" charset="0"/>
+                <a:ea typeface="Malgun Gothic" pitchFamily="34" charset="-122"/>
+                <a:cs typeface="Malgun Gothic" pitchFamily="34" charset="-120"/>
+              </a:rPr>
+              <a:t>→</a:t>
+            </a:r>
+            <a:endParaRPr lang="en-US" sz="1400" dirty="0"/>
           </a:p>
         </p:txBody>
       </p:sp>
@@ -6139,85 +6085,7 @@
         </p:nvSpPr>
         <p:spPr>
           <a:xfrm>
-            <a:off x="406220" y="3311277"/>
-            <a:ext cx="4547158" cy="142875"/>
-          </a:xfrm>
-          <a:prstGeom prst="rect">
-            <a:avLst/>
-          </a:prstGeom>
-          <a:noFill/>
-          <a:ln/>
-        </p:spPr>
-        <p:txBody>
-          <a:bodyPr wrap="square" lIns="0" tIns="0" rIns="0" bIns="0" rtlCol="0" anchor="t"/>
-          <a:lstStyle/>
-          <a:p>
-            <a:pPr algn="ctr" indent="0" marL="0">
-              <a:buNone/>
-            </a:pPr>
-            <a:r>
-              <a:rPr lang="en-US" sz="900" dirty="0">
-                <a:solidFill>
-                  <a:srgbClr val="666666"/>
-                </a:solidFill>
-                <a:latin typeface="Malgun Gothic" pitchFamily="34" charset="0"/>
-                <a:ea typeface="Malgun Gothic" pitchFamily="34" charset="-122"/>
-                <a:cs typeface="Malgun Gothic" pitchFamily="34" charset="-120"/>
-              </a:rPr>
-              <a:t>다음 요청 추출 · LLM 백엔드로 전달</a:t>
-            </a:r>
-            <a:endParaRPr lang="en-US" sz="900" dirty="0"/>
-          </a:p>
-        </p:txBody>
-      </p:sp>
-      <p:sp>
-        <p:nvSpPr>
-          <p:cNvPr id="38" name="Text 36"/>
-          <p:cNvSpPr/>
-          <p:nvPr/>
-        </p:nvSpPr>
-        <p:spPr>
-          <a:xfrm>
-            <a:off x="5130998" y="3201739"/>
-            <a:ext cx="181407" cy="209550"/>
-          </a:xfrm>
-          <a:prstGeom prst="rect">
-            <a:avLst/>
-          </a:prstGeom>
-          <a:noFill/>
-          <a:ln/>
-        </p:spPr>
-        <p:txBody>
-          <a:bodyPr wrap="square" lIns="0" tIns="0" rIns="0" bIns="0" rtlCol="0" anchor="t"/>
-          <a:lstStyle/>
-          <a:p>
-            <a:pPr algn="l" indent="0" marL="0">
-              <a:buNone/>
-            </a:pPr>
-            <a:r>
-              <a:rPr lang="en-US" sz="1400" dirty="0">
-                <a:solidFill>
-                  <a:srgbClr val="2B579A"/>
-                </a:solidFill>
-                <a:latin typeface="Malgun Gothic" pitchFamily="34" charset="0"/>
-                <a:ea typeface="Malgun Gothic" pitchFamily="34" charset="-122"/>
-                <a:cs typeface="Malgun Gothic" pitchFamily="34" charset="-120"/>
-              </a:rPr>
-              <a:t>→</a:t>
-            </a:r>
-            <a:endParaRPr lang="en-US" sz="1400" dirty="0"/>
-          </a:p>
-        </p:txBody>
-      </p:sp>
-      <p:sp>
-        <p:nvSpPr>
-          <p:cNvPr id="39" name="Text 37"/>
-          <p:cNvSpPr/>
-          <p:nvPr/>
-        </p:nvSpPr>
-        <p:spPr>
-          <a:xfrm>
-            <a:off x="5385048" y="2966889"/>
+            <a:off x="5385048" y="2766864"/>
             <a:ext cx="1688902" cy="679252"/>
           </a:xfrm>
           <a:prstGeom prst="rect">
@@ -6245,40 +6113,118 @@
       </p:sp>
       <p:sp>
         <p:nvSpPr>
+          <p:cNvPr id="38" name="Text 36"/>
+          <p:cNvSpPr/>
+          <p:nvPr/>
+        </p:nvSpPr>
+        <p:spPr>
+          <a:xfrm>
+            <a:off x="5517079" y="2963614"/>
+            <a:ext cx="1424839" cy="142875"/>
+          </a:xfrm>
+          <a:prstGeom prst="rect">
+            <a:avLst/>
+          </a:prstGeom>
+          <a:noFill/>
+          <a:ln/>
+        </p:spPr>
+        <p:txBody>
+          <a:bodyPr wrap="square" lIns="0" tIns="0" rIns="0" bIns="0" rtlCol="0" anchor="t"/>
+          <a:lstStyle/>
+          <a:p>
+            <a:pPr algn="ctr" indent="0" marL="0">
+              <a:buNone/>
+            </a:pPr>
+            <a:r>
+              <a:rPr lang="en-US" sz="1000" b="1" dirty="0">
+                <a:solidFill>
+                  <a:srgbClr val="FFFFFF"/>
+                </a:solidFill>
+                <a:latin typeface="Malgun Gothic" pitchFamily="34" charset="0"/>
+                <a:ea typeface="Malgun Gothic" pitchFamily="34" charset="-122"/>
+                <a:cs typeface="Malgun Gothic" pitchFamily="34" charset="-120"/>
+              </a:rPr>
+              <a:t>Ollama (LLM)</a:t>
+            </a:r>
+            <a:endParaRPr lang="en-US" sz="1000" dirty="0"/>
+          </a:p>
+        </p:txBody>
+      </p:sp>
+      <p:sp>
+        <p:nvSpPr>
+          <p:cNvPr id="39" name="Text 37"/>
+          <p:cNvSpPr/>
+          <p:nvPr/>
+        </p:nvSpPr>
+        <p:spPr>
+          <a:xfrm>
+            <a:off x="5517079" y="3106489"/>
+            <a:ext cx="1424839" cy="142875"/>
+          </a:xfrm>
+          <a:prstGeom prst="rect">
+            <a:avLst/>
+          </a:prstGeom>
+          <a:noFill/>
+          <a:ln/>
+        </p:spPr>
+        <p:txBody>
+          <a:bodyPr wrap="square" lIns="0" tIns="0" rIns="0" bIns="0" rtlCol="0" anchor="t"/>
+          <a:lstStyle/>
+          <a:p>
+            <a:pPr algn="ctr" indent="0" marL="0">
+              <a:buNone/>
+            </a:pPr>
+            <a:r>
+              <a:rPr lang="en-US" sz="900" dirty="0">
+                <a:solidFill>
+                  <a:srgbClr val="CCCCCC"/>
+                </a:solidFill>
+                <a:latin typeface="Malgun Gothic" pitchFamily="34" charset="0"/>
+                <a:ea typeface="Malgun Gothic" pitchFamily="34" charset="-122"/>
+                <a:cs typeface="Malgun Gothic" pitchFamily="34" charset="-120"/>
+              </a:rPr>
+              <a:t>로컬 추론</a:t>
+            </a:r>
+            <a:endParaRPr lang="en-US" sz="900" dirty="0"/>
+          </a:p>
+        </p:txBody>
+      </p:sp>
+      <p:sp>
+        <p:nvSpPr>
           <p:cNvPr id="40" name="Text 38"/>
           <p:cNvSpPr/>
           <p:nvPr/>
         </p:nvSpPr>
         <p:spPr>
           <a:xfrm>
-            <a:off x="5517079" y="3163639"/>
-            <a:ext cx="1424839" cy="142875"/>
-          </a:xfrm>
-          <a:prstGeom prst="rect">
-            <a:avLst/>
-          </a:prstGeom>
-          <a:noFill/>
-          <a:ln/>
-        </p:spPr>
-        <p:txBody>
-          <a:bodyPr wrap="square" lIns="0" tIns="0" rIns="0" bIns="0" rtlCol="0" anchor="t"/>
-          <a:lstStyle/>
-          <a:p>
-            <a:pPr algn="ctr" indent="0" marL="0">
-              <a:buNone/>
-            </a:pPr>
-            <a:r>
-              <a:rPr lang="en-US" sz="1000" b="1" dirty="0">
-                <a:solidFill>
-                  <a:srgbClr val="FFFFFF"/>
-                </a:solidFill>
-                <a:latin typeface="Malgun Gothic" pitchFamily="34" charset="0"/>
-                <a:ea typeface="Malgun Gothic" pitchFamily="34" charset="-122"/>
-                <a:cs typeface="Malgun Gothic" pitchFamily="34" charset="-120"/>
-              </a:rPr>
-              <a:t>Ollama (LLM)</a:t>
-            </a:r>
-            <a:endParaRPr lang="en-US" sz="1000" dirty="0"/>
+            <a:off x="7150150" y="3001714"/>
+            <a:ext cx="181407" cy="209550"/>
+          </a:xfrm>
+          <a:prstGeom prst="rect">
+            <a:avLst/>
+          </a:prstGeom>
+          <a:noFill/>
+          <a:ln/>
+        </p:spPr>
+        <p:txBody>
+          <a:bodyPr wrap="square" lIns="0" tIns="0" rIns="0" bIns="0" rtlCol="0" anchor="t"/>
+          <a:lstStyle/>
+          <a:p>
+            <a:pPr algn="l" indent="0" marL="0">
+              <a:buNone/>
+            </a:pPr>
+            <a:r>
+              <a:rPr lang="en-US" sz="1400" dirty="0">
+                <a:solidFill>
+                  <a:srgbClr val="2B579A"/>
+                </a:solidFill>
+                <a:latin typeface="Malgun Gothic" pitchFamily="34" charset="0"/>
+                <a:ea typeface="Malgun Gothic" pitchFamily="34" charset="-122"/>
+                <a:cs typeface="Malgun Gothic" pitchFamily="34" charset="-120"/>
+              </a:rPr>
+              <a:t>→</a:t>
+            </a:r>
+            <a:endParaRPr lang="en-US" sz="1400" dirty="0"/>
           </a:p>
         </p:txBody>
       </p:sp>
@@ -6290,85 +6236,7 @@
         </p:nvSpPr>
         <p:spPr>
           <a:xfrm>
-            <a:off x="5517079" y="3306514"/>
-            <a:ext cx="1424839" cy="142875"/>
-          </a:xfrm>
-          <a:prstGeom prst="rect">
-            <a:avLst/>
-          </a:prstGeom>
-          <a:noFill/>
-          <a:ln/>
-        </p:spPr>
-        <p:txBody>
-          <a:bodyPr wrap="square" lIns="0" tIns="0" rIns="0" bIns="0" rtlCol="0" anchor="t"/>
-          <a:lstStyle/>
-          <a:p>
-            <a:pPr algn="ctr" indent="0" marL="0">
-              <a:buNone/>
-            </a:pPr>
-            <a:r>
-              <a:rPr lang="en-US" sz="900" dirty="0">
-                <a:solidFill>
-                  <a:srgbClr val="CCCCCC"/>
-                </a:solidFill>
-                <a:latin typeface="Malgun Gothic" pitchFamily="34" charset="0"/>
-                <a:ea typeface="Malgun Gothic" pitchFamily="34" charset="-122"/>
-                <a:cs typeface="Malgun Gothic" pitchFamily="34" charset="-120"/>
-              </a:rPr>
-              <a:t>로컬 추론</a:t>
-            </a:r>
-            <a:endParaRPr lang="en-US" sz="900" dirty="0"/>
-          </a:p>
-        </p:txBody>
-      </p:sp>
-      <p:sp>
-        <p:nvSpPr>
-          <p:cNvPr id="42" name="Text 40"/>
-          <p:cNvSpPr/>
-          <p:nvPr/>
-        </p:nvSpPr>
-        <p:spPr>
-          <a:xfrm>
-            <a:off x="7150150" y="3201739"/>
-            <a:ext cx="181407" cy="209550"/>
-          </a:xfrm>
-          <a:prstGeom prst="rect">
-            <a:avLst/>
-          </a:prstGeom>
-          <a:noFill/>
-          <a:ln/>
-        </p:spPr>
-        <p:txBody>
-          <a:bodyPr wrap="square" lIns="0" tIns="0" rIns="0" bIns="0" rtlCol="0" anchor="t"/>
-          <a:lstStyle/>
-          <a:p>
-            <a:pPr algn="l" indent="0" marL="0">
-              <a:buNone/>
-            </a:pPr>
-            <a:r>
-              <a:rPr lang="en-US" sz="1400" dirty="0">
-                <a:solidFill>
-                  <a:srgbClr val="2B579A"/>
-                </a:solidFill>
-                <a:latin typeface="Malgun Gothic" pitchFamily="34" charset="0"/>
-                <a:ea typeface="Malgun Gothic" pitchFamily="34" charset="-122"/>
-                <a:cs typeface="Malgun Gothic" pitchFamily="34" charset="-120"/>
-              </a:rPr>
-              <a:t>→</a:t>
-            </a:r>
-            <a:endParaRPr lang="en-US" sz="1400" dirty="0"/>
-          </a:p>
-        </p:txBody>
-      </p:sp>
-      <p:sp>
-        <p:nvSpPr>
-          <p:cNvPr id="43" name="Text 41"/>
-          <p:cNvSpPr/>
-          <p:nvPr/>
-        </p:nvSpPr>
-        <p:spPr>
-          <a:xfrm>
-            <a:off x="7404199" y="2966889"/>
+            <a:off x="7404199" y="2766864"/>
             <a:ext cx="1435001" cy="679252"/>
           </a:xfrm>
           <a:prstGeom prst="rect">
@@ -6396,14 +6264,92 @@
       </p:sp>
       <p:sp>
         <p:nvSpPr>
+          <p:cNvPr id="42" name="Text 40"/>
+          <p:cNvSpPr/>
+          <p:nvPr/>
+        </p:nvSpPr>
+        <p:spPr>
+          <a:xfrm>
+            <a:off x="7538770" y="2887414"/>
+            <a:ext cx="1165860" cy="152400"/>
+          </a:xfrm>
+          <a:prstGeom prst="rect">
+            <a:avLst/>
+          </a:prstGeom>
+          <a:noFill/>
+          <a:ln/>
+        </p:spPr>
+        <p:txBody>
+          <a:bodyPr wrap="square" lIns="0" tIns="0" rIns="0" bIns="0" rtlCol="0" anchor="t"/>
+          <a:lstStyle/>
+          <a:p>
+            <a:pPr algn="ctr" indent="0" marL="0">
+              <a:buNone/>
+            </a:pPr>
+            <a:r>
+              <a:rPr lang="en-US" sz="1000" b="1" dirty="0">
+                <a:solidFill>
+                  <a:srgbClr val="333333"/>
+                </a:solidFill>
+                <a:latin typeface="Malgun Gothic" pitchFamily="34" charset="0"/>
+                <a:ea typeface="Malgun Gothic" pitchFamily="34" charset="-122"/>
+                <a:cs typeface="Malgun Gothic" pitchFamily="34" charset="-120"/>
+              </a:rPr>
+              <a:t>응답</a:t>
+            </a:r>
+            <a:endParaRPr lang="en-US" sz="1000" dirty="0"/>
+          </a:p>
+        </p:txBody>
+      </p:sp>
+      <p:sp>
+        <p:nvSpPr>
+          <p:cNvPr id="43" name="Text 41"/>
+          <p:cNvSpPr/>
+          <p:nvPr/>
+        </p:nvSpPr>
+        <p:spPr>
+          <a:xfrm>
+            <a:off x="7538770" y="3039814"/>
+            <a:ext cx="1165860" cy="142875"/>
+          </a:xfrm>
+          <a:prstGeom prst="rect">
+            <a:avLst/>
+          </a:prstGeom>
+          <a:noFill/>
+          <a:ln/>
+        </p:spPr>
+        <p:txBody>
+          <a:bodyPr wrap="square" lIns="0" tIns="0" rIns="0" bIns="0" rtlCol="0" anchor="t"/>
+          <a:lstStyle/>
+          <a:p>
+            <a:pPr algn="ctr" indent="0" marL="0">
+              <a:buNone/>
+            </a:pPr>
+            <a:r>
+              <a:rPr lang="en-US" sz="900" dirty="0">
+                <a:solidFill>
+                  <a:srgbClr val="666666"/>
+                </a:solidFill>
+                <a:latin typeface="Malgun Gothic" pitchFamily="34" charset="0"/>
+                <a:ea typeface="Malgun Gothic" pitchFamily="34" charset="-122"/>
+                <a:cs typeface="Malgun Gothic" pitchFamily="34" charset="-120"/>
+              </a:rPr>
+              <a:t>대기시간 기록</a:t>
+            </a:r>
+            <a:endParaRPr lang="en-US" sz="900" dirty="0"/>
+          </a:p>
+        </p:txBody>
+      </p:sp>
+      <p:sp>
+        <p:nvSpPr>
           <p:cNvPr id="44" name="Text 42"/>
           <p:cNvSpPr/>
           <p:nvPr/>
         </p:nvSpPr>
         <p:spPr>
           <a:xfrm>
-            <a:off x="7538770" y="3087439"/>
-            <a:ext cx="1165860" cy="152400"/>
+            <a:off x="7538770" y="3182689"/>
+            <a:ext cx="1165860" cy="142875"/>
           </a:xfrm>
           <a:prstGeom prst="rect">
             <a:avLst/>
@@ -6419,45 +6365,6 @@
               <a:buNone/>
             </a:pPr>
             <a:r>
-              <a:rPr lang="en-US" sz="1000" b="1" dirty="0">
-                <a:solidFill>
-                  <a:srgbClr val="333333"/>
-                </a:solidFill>
-                <a:latin typeface="Malgun Gothic" pitchFamily="34" charset="0"/>
-                <a:ea typeface="Malgun Gothic" pitchFamily="34" charset="-122"/>
-                <a:cs typeface="Malgun Gothic" pitchFamily="34" charset="-120"/>
-              </a:rPr>
-              <a:t>응답</a:t>
-            </a:r>
-            <a:endParaRPr lang="en-US" sz="1000" dirty="0"/>
-          </a:p>
-        </p:txBody>
-      </p:sp>
-      <p:sp>
-        <p:nvSpPr>
-          <p:cNvPr id="45" name="Text 43"/>
-          <p:cNvSpPr/>
-          <p:nvPr/>
-        </p:nvSpPr>
-        <p:spPr>
-          <a:xfrm>
-            <a:off x="7538770" y="3239839"/>
-            <a:ext cx="1165860" cy="142875"/>
-          </a:xfrm>
-          <a:prstGeom prst="rect">
-            <a:avLst/>
-          </a:prstGeom>
-          <a:noFill/>
-          <a:ln/>
-        </p:spPr>
-        <p:txBody>
-          <a:bodyPr wrap="square" lIns="0" tIns="0" rIns="0" bIns="0" rtlCol="0" anchor="t"/>
-          <a:lstStyle/>
-          <a:p>
-            <a:pPr algn="ctr" indent="0" marL="0">
-              <a:buNone/>
-            </a:pPr>
-            <a:r>
               <a:rPr lang="en-US" sz="900" dirty="0">
                 <a:solidFill>
                   <a:srgbClr val="666666"/>
@@ -6466,7 +6373,7 @@
                 <a:ea typeface="Malgun Gothic" pitchFamily="34" charset="-122"/>
                 <a:cs typeface="Malgun Gothic" pitchFamily="34" charset="-120"/>
               </a:rPr>
-              <a:t>대기시간 기록</a:t>
+              <a:t>JFI 계산</a:t>
             </a:r>
             <a:endParaRPr lang="en-US" sz="900" dirty="0"/>
           </a:p>
@@ -6474,46 +6381,7 @@
       </p:sp>
       <p:sp>
         <p:nvSpPr>
-          <p:cNvPr id="46" name="Text 44"/>
-          <p:cNvSpPr/>
-          <p:nvPr/>
-        </p:nvSpPr>
-        <p:spPr>
-          <a:xfrm>
-            <a:off x="7538770" y="3382714"/>
-            <a:ext cx="1165860" cy="142875"/>
-          </a:xfrm>
-          <a:prstGeom prst="rect">
-            <a:avLst/>
-          </a:prstGeom>
-          <a:noFill/>
-          <a:ln/>
-        </p:spPr>
-        <p:txBody>
-          <a:bodyPr wrap="square" lIns="0" tIns="0" rIns="0" bIns="0" rtlCol="0" anchor="t"/>
-          <a:lstStyle/>
-          <a:p>
-            <a:pPr algn="ctr" indent="0" marL="0">
-              <a:buNone/>
-            </a:pPr>
-            <a:r>
-              <a:rPr lang="en-US" sz="900" dirty="0">
-                <a:solidFill>
-                  <a:srgbClr val="666666"/>
-                </a:solidFill>
-                <a:latin typeface="Malgun Gothic" pitchFamily="34" charset="0"/>
-                <a:ea typeface="Malgun Gothic" pitchFamily="34" charset="-122"/>
-                <a:cs typeface="Malgun Gothic" pitchFamily="34" charset="-120"/>
-              </a:rPr>
-              <a:t>JFI 계산</a:t>
-            </a:r>
-            <a:endParaRPr lang="en-US" sz="900" dirty="0"/>
-          </a:p>
-        </p:txBody>
-      </p:sp>
-      <p:sp>
-        <p:nvSpPr>
-          <p:cNvPr id="47" name="Shape 45"/>
+          <p:cNvPr id="45" name="Shape 43"/>
           <p:cNvSpPr/>
           <p:nvPr/>
         </p:nvSpPr>
@@ -6536,7 +6404,7 @@
       </p:sp>
       <p:sp>
         <p:nvSpPr>
-          <p:cNvPr id="48" name="Text 46"/>
+          <p:cNvPr id="46" name="Text 44"/>
           <p:cNvSpPr/>
           <p:nvPr/>
         </p:nvSpPr>

</xml_diff>

<commit_message>
Update proposal figures and slides for version 28
- Updated generate-proposal-figures.js to reflect changes in slide content and versioning.
- Modified slide1-algo-comparison.html to replace "공정성 지표(JFI) 측정" with "GPS 모델 근사 구현" and updated references.
- Changed slide2-architecture.html to specify "사용자 등급에 따른 자원 배분" instead of "테넌트 등급에 따른 자원 배분".
- Added new slide3-request-flow.html detailing the request flow phases.
- Updated proposal figures in proposal-figures.pptx and proposal.docx to align with the latest changes.
</commit_message>
<xml_diff>
--- a/04-proposal/figures/proposal-figures.pptx
+++ b/04-proposal/figures/proposal-figures.pptx
@@ -2403,7 +2403,7 @@
                 <a:ea typeface="Malgun Gothic" pitchFamily="34" charset="-122"/>
                 <a:cs typeface="Malgun Gothic" pitchFamily="34" charset="-120"/>
               </a:rPr>
-              <a:t>공정성 지표(JFI) 측정</a:t>
+              <a:t>GPS 모델 근사 구현</a:t>
             </a:r>
             <a:endParaRPr lang="en-US" sz="950" dirty="0"/>
           </a:p>
@@ -2712,7 +2712,7 @@
                 <a:ea typeface="Malgun Gothic" pitchFamily="34" charset="-122"/>
                 <a:cs typeface="Malgun Gothic" pitchFamily="34" charset="-120"/>
               </a:rPr>
-              <a:t>[1] Silberschatz et al., Operating System Concepts, 10th ed., 2018.  [2] Arpaci-Dusseau, OSTEP, v1.10, 2023.  [3] Kurose &amp; Ross, Computer Networking, 8th ed., 2021.</a:t>
+              <a:t>[3] Silberschatz et al., Operating System Concepts, 10th ed., 2018.  [4] Arpaci-Dusseau, OSTEP, v1.10, 2023.  [5] Kurose &amp; Ross, Computer Networking, 9th ed., 2025.</a:t>
             </a:r>
             <a:endParaRPr lang="en-US" sz="700" dirty="0"/>
           </a:p>
@@ -3756,7 +3756,7 @@
                 <a:ea typeface="Malgun Gothic" pitchFamily="34" charset="-122"/>
                 <a:cs typeface="Malgun Gothic" pitchFamily="34" charset="-120"/>
               </a:rPr>
-              <a:t>테넌트 등급에 따른 자원 배분</a:t>
+              <a:t>사용자 등급에 따른 자원 배분</a:t>
             </a:r>
             <a:endParaRPr lang="en-US" sz="900" dirty="0"/>
           </a:p>

</xml_diff>